<commit_message>
Setup, Intro and Bluetooth slides updated.
</commit_message>
<xml_diff>
--- a/0 ACT AW - Setup.pptx
+++ b/0 ACT AW - Setup.pptx
@@ -5,16 +5,17 @@
     <p:sldMasterId id="2147483702" r:id="rId5"/>
   </p:sldMasterIdLst>
   <p:notesMasterIdLst>
-    <p:notesMasterId r:id="rId8"/>
+    <p:notesMasterId r:id="rId9"/>
   </p:notesMasterIdLst>
   <p:sldIdLst>
     <p:sldId id="508" r:id="rId6"/>
     <p:sldId id="509" r:id="rId7"/>
+    <p:sldId id="510" r:id="rId8"/>
   </p:sldIdLst>
   <p:sldSz cx="12192000" cy="6858000"/>
   <p:notesSz cx="6858000" cy="9144000"/>
   <p:custDataLst>
-    <p:tags r:id="rId9"/>
+    <p:tags r:id="rId10"/>
   </p:custDataLst>
   <p:defaultTextStyle>
     <a:defPPr>
@@ -122,6 +123,11 @@
         <p14:section name="Kali Linux" id="{AF6FF401-F398-49CD-982E-520170691C75}">
           <p14:sldIdLst>
             <p14:sldId id="509"/>
+          </p14:sldIdLst>
+        </p14:section>
+        <p14:section name="Kali Setups" id="{F21FF69F-C6E5-4856-A936-324FF15B4646}">
+          <p14:sldIdLst>
+            <p14:sldId id="510"/>
           </p14:sldIdLst>
         </p14:section>
       </p14:sectionLst>
@@ -6294,13 +6300,6 @@
             <a:pPr marL="971550" lvl="1" indent="-285750"/>
             <a:r>
               <a:rPr lang="en-US" sz="1600" dirty="0"/>
-              <a:t>Reboot</a:t>
-            </a:r>
-          </a:p>
-          <a:p>
-            <a:pPr marL="971550" lvl="1" indent="-285750"/>
-            <a:r>
-              <a:rPr lang="en-US" sz="1600" dirty="0"/>
               <a:t>Run VirtualBox</a:t>
             </a:r>
           </a:p>
@@ -6320,6 +6319,17 @@
               <a:t>How to Install VirtualBox Extension Pack</a:t>
             </a:r>
             <a:endParaRPr lang="en-US" sz="1400" dirty="0"/>
+          </a:p>
+          <a:p>
+            <a:pPr marL="285750" indent="-285750"/>
+            <a:endParaRPr lang="en-US" dirty="0"/>
+          </a:p>
+          <a:p>
+            <a:pPr marL="285750" indent="-285750"/>
+            <a:r>
+              <a:rPr lang="en-US" dirty="0"/>
+              <a:t>Next Slide: Kali Linux</a:t>
+            </a:r>
           </a:p>
           <a:p>
             <a:endParaRPr lang="en-US" dirty="0"/>
@@ -6403,11 +6413,13 @@
         <p:spPr>
           <a:xfrm>
             <a:off x="270415" y="640080"/>
-            <a:ext cx="11658059" cy="5405120"/>
+            <a:ext cx="11658059" cy="6009888"/>
           </a:xfrm>
         </p:spPr>
         <p:txBody>
-          <a:bodyPr/>
+          <a:bodyPr>
+            <a:normAutofit fontScale="77500" lnSpcReduction="20000"/>
+          </a:bodyPr>
           <a:lstStyle/>
           <a:p>
             <a:r>
@@ -6430,6 +6442,16 @@
               <a:rPr lang="en-US" dirty="0"/>
               <a:t>Kali Linux VirtualBox VM</a:t>
             </a:r>
+            <a:endParaRPr lang="en-US" sz="2200" dirty="0">
+              <a:hlinkClick r:id="rId2"/>
+            </a:endParaRPr>
+          </a:p>
+          <a:p>
+            <a:pPr marL="971550" lvl="1" indent="-285750"/>
+            <a:r>
+              <a:rPr lang="en-US" sz="1600" dirty="0"/>
+              <a:t>Install VirtualBox (previous slide) </a:t>
+            </a:r>
           </a:p>
           <a:p>
             <a:pPr marL="971550" lvl="1" indent="-285750"/>
@@ -6448,24 +6470,78 @@
             <a:pPr marL="971550" lvl="1" indent="-285750"/>
             <a:r>
               <a:rPr lang="en-US" sz="1600" dirty="0"/>
-              <a:t>Add the VM and open the file from inside VirtualBox </a:t>
-            </a:r>
-          </a:p>
-          <a:p>
-            <a:pPr marL="971550" lvl="1" indent="-285750"/>
+              <a:t>Unpack the .7z file (install 7-Zip from </a:t>
+            </a:r>
             <a:r>
               <a:rPr lang="en-US" sz="1600" dirty="0">
                 <a:hlinkClick r:id="rId3"/>
               </a:rPr>
+              <a:t>https://7-zip.org/download.html</a:t>
+            </a:r>
+            <a:r>
+              <a:rPr lang="en-US" sz="1600" dirty="0"/>
+              <a:t> and use that to unpack it) </a:t>
+            </a:r>
+          </a:p>
+          <a:p>
+            <a:pPr marL="1428750" lvl="2" indent="-285750"/>
+            <a:r>
+              <a:rPr lang="en-US" sz="1200" dirty="0"/>
+              <a:t>On Windows 11, you may have to show more options after right clicking</a:t>
+            </a:r>
+          </a:p>
+          <a:p>
+            <a:pPr marL="1428750" lvl="2" indent="-285750"/>
+            <a:r>
+              <a:rPr lang="en-US" sz="1200" dirty="0"/>
+              <a:t>Extract Here (from Download directory)</a:t>
+            </a:r>
+          </a:p>
+          <a:p>
+            <a:pPr marL="971550" lvl="1" indent="-285750"/>
+            <a:r>
+              <a:rPr lang="en-US" sz="1600" dirty="0"/>
+              <a:t>Add the VM and open the .</a:t>
+            </a:r>
+            <a:r>
+              <a:rPr lang="en-US" sz="1600" dirty="0" err="1"/>
+              <a:t>vbox</a:t>
+            </a:r>
+            <a:r>
+              <a:rPr lang="en-US" sz="1600" dirty="0"/>
+              <a:t> file from inside VirtualBox </a:t>
+            </a:r>
+          </a:p>
+          <a:p>
+            <a:pPr marL="971550" lvl="1" indent="-285750"/>
+            <a:r>
+              <a:rPr lang="en-US" sz="1600" dirty="0">
+                <a:hlinkClick r:id="rId4"/>
+              </a:rPr>
               <a:t>How to Install Kali Linux in VirtualBox: Complete Setup Guide – </a:t>
             </a:r>
             <a:r>
               <a:rPr lang="en-US" sz="1600" dirty="0" err="1">
-                <a:hlinkClick r:id="rId3"/>
+                <a:hlinkClick r:id="rId4"/>
               </a:rPr>
               <a:t>LinuxForDevices</a:t>
             </a:r>
             <a:endParaRPr lang="en-US" sz="1600" dirty="0"/>
+          </a:p>
+          <a:p>
+            <a:pPr marL="971550" lvl="1" indent="-285750"/>
+            <a:r>
+              <a:rPr lang="en-US" sz="1600" dirty="0"/>
+              <a:t>Default </a:t>
+            </a:r>
+            <a:r>
+              <a:rPr lang="en-US" sz="1600" dirty="0" err="1"/>
+              <a:t>userid</a:t>
+            </a:r>
+            <a:r>
+              <a:rPr lang="en-US" sz="1600" dirty="0"/>
+              <a:t> &amp; password are both “kali”</a:t>
+            </a:r>
           </a:p>
           <a:p>
             <a:pPr marL="285750" indent="-285750">
@@ -6481,7 +6557,7 @@
             <a:pPr marL="971550" lvl="1" indent="-285750"/>
             <a:r>
               <a:rPr lang="en-US" sz="1600" dirty="0">
-                <a:hlinkClick r:id="rId4"/>
+                <a:hlinkClick r:id="rId5"/>
               </a:rPr>
               <a:t>Get Kali | Kali Linux</a:t>
             </a:r>
@@ -6508,10 +6584,184 @@
             <a:pPr marL="971550" lvl="1" indent="-285750"/>
             <a:r>
               <a:rPr lang="en-US" sz="1600" dirty="0">
-                <a:hlinkClick r:id="rId5"/>
+                <a:hlinkClick r:id="rId6"/>
               </a:rPr>
               <a:t>Making a Kali Bootable USB Drive on Windows | Kali Linux Documentation</a:t>
             </a:r>
+            <a:endParaRPr lang="en-US" sz="1600" dirty="0"/>
+          </a:p>
+          <a:p>
+            <a:pPr marL="971550" lvl="1" indent="-285750"/>
+            <a:r>
+              <a:rPr lang="en-US" sz="1600" dirty="0"/>
+              <a:t>Remember your </a:t>
+            </a:r>
+            <a:r>
+              <a:rPr lang="en-US" sz="1600" dirty="0" err="1"/>
+              <a:t>userid</a:t>
+            </a:r>
+            <a:r>
+              <a:rPr lang="en-US" sz="1600" dirty="0"/>
+              <a:t> &amp; password</a:t>
+            </a:r>
+          </a:p>
+          <a:p>
+            <a:pPr marL="285750" indent="-285750">
+              <a:buFont typeface="Arial" panose="020B0604020202020204" pitchFamily="34" charset="0"/>
+              <a:buChar char="•"/>
+            </a:pPr>
+            <a:r>
+              <a:rPr lang="en-US" dirty="0"/>
+              <a:t>Updating it</a:t>
+            </a:r>
+          </a:p>
+          <a:p>
+            <a:pPr lvl="1"/>
+            <a:r>
+              <a:rPr lang="en-US" sz="1600" dirty="0"/>
+              <a:t>Recommend updating Kali Linux by opening a Terminal Emulator Window.  </a:t>
+            </a:r>
+            <a:r>
+              <a:rPr lang="en-US" sz="1600" dirty="0">
+                <a:solidFill>
+                  <a:srgbClr val="FF0000"/>
+                </a:solidFill>
+              </a:rPr>
+              <a:t>This may take awhile</a:t>
+            </a:r>
+          </a:p>
+          <a:p>
+            <a:pPr lvl="2"/>
+            <a:r>
+              <a:rPr lang="en-US" sz="1400" dirty="0" err="1"/>
+              <a:t>sudo</a:t>
+            </a:r>
+            <a:r>
+              <a:rPr lang="en-US" sz="1400" dirty="0"/>
+              <a:t> apt update; </a:t>
+            </a:r>
+            <a:r>
+              <a:rPr lang="en-US" sz="1400" dirty="0" err="1"/>
+              <a:t>sudo</a:t>
+            </a:r>
+            <a:r>
+              <a:rPr lang="en-US" sz="1400" dirty="0"/>
+              <a:t> apt </a:t>
+            </a:r>
+            <a:r>
+              <a:rPr lang="en-US" sz="1400" dirty="0" err="1"/>
+              <a:t>dist</a:t>
+            </a:r>
+            <a:r>
+              <a:rPr lang="en-US" sz="1400" dirty="0"/>
+              <a:t>-upgrade</a:t>
+            </a:r>
+          </a:p>
+          <a:p>
+            <a:pPr lvl="1"/>
+            <a:r>
+              <a:rPr lang="en-US" sz="1600" dirty="0"/>
+              <a:t>Reboot</a:t>
+            </a:r>
+          </a:p>
+          <a:p>
+            <a:pPr marL="285750" indent="-285750">
+              <a:buFont typeface="Arial" panose="020B0604020202020204" pitchFamily="34" charset="0"/>
+              <a:buChar char="•"/>
+            </a:pPr>
+            <a:r>
+              <a:rPr lang="en-US" dirty="0"/>
+              <a:t>Installing Guest Additions/s</a:t>
+            </a:r>
+          </a:p>
+          <a:p>
+            <a:pPr marL="971550" lvl="1" indent="-285750"/>
+            <a:r>
+              <a:rPr lang="en-US" sz="1500" dirty="0"/>
+              <a:t>From the Menu bar/Devices/Insert Guest Additions CD image…</a:t>
+            </a:r>
+          </a:p>
+          <a:p>
+            <a:pPr marL="971550" lvl="1" indent="-285750"/>
+            <a:r>
+              <a:rPr lang="en-US" sz="1500" dirty="0"/>
+              <a:t>From Terminal Emulator Window:</a:t>
+            </a:r>
+          </a:p>
+          <a:p>
+            <a:pPr marL="1428750" lvl="2" indent="-285750"/>
+            <a:r>
+              <a:rPr lang="en-US" sz="1400" dirty="0">
+                <a:latin typeface="Consolas" panose="020B0609020204030204" pitchFamily="49" charset="0"/>
+              </a:rPr>
+              <a:t>cd /run/media/kali/VBox_Gas_7.2.20</a:t>
+            </a:r>
+          </a:p>
+          <a:p>
+            <a:pPr marL="1428750" lvl="2" indent="-285750"/>
+            <a:r>
+              <a:rPr lang="en-US" sz="1400" dirty="0" err="1">
+                <a:latin typeface="Consolas" panose="020B0609020204030204" pitchFamily="49" charset="0"/>
+              </a:rPr>
+              <a:t>sudo</a:t>
+            </a:r>
+            <a:r>
+              <a:rPr lang="en-US" sz="1400" dirty="0">
+                <a:latin typeface="Consolas" panose="020B0609020204030204" pitchFamily="49" charset="0"/>
+              </a:rPr>
+              <a:t> apt-get install -y </a:t>
+            </a:r>
+            <a:r>
+              <a:rPr lang="en-US" sz="1400" dirty="0" err="1">
+                <a:latin typeface="Consolas" panose="020B0609020204030204" pitchFamily="49" charset="0"/>
+              </a:rPr>
+              <a:t>linux</a:t>
+            </a:r>
+            <a:r>
+              <a:rPr lang="en-US" sz="1400" dirty="0">
+                <a:latin typeface="Consolas" panose="020B0609020204030204" pitchFamily="49" charset="0"/>
+              </a:rPr>
+              <a:t>-headers-$(</a:t>
+            </a:r>
+            <a:r>
+              <a:rPr lang="en-US" sz="1400" dirty="0" err="1">
+                <a:latin typeface="Consolas" panose="020B0609020204030204" pitchFamily="49" charset="0"/>
+              </a:rPr>
+              <a:t>uname</a:t>
+            </a:r>
+            <a:r>
+              <a:rPr lang="en-US" sz="1400" dirty="0">
+                <a:latin typeface="Consolas" panose="020B0609020204030204" pitchFamily="49" charset="0"/>
+              </a:rPr>
+              <a:t> -r)</a:t>
+            </a:r>
+          </a:p>
+          <a:p>
+            <a:pPr marL="1428750" lvl="2" indent="-285750"/>
+            <a:r>
+              <a:rPr lang="en-US" sz="1400" dirty="0" err="1">
+                <a:latin typeface="Consolas" panose="020B0609020204030204" pitchFamily="49" charset="0"/>
+              </a:rPr>
+              <a:t>sudo</a:t>
+            </a:r>
+            <a:r>
+              <a:rPr lang="en-US" sz="1400" dirty="0">
+                <a:latin typeface="Consolas" panose="020B0609020204030204" pitchFamily="49" charset="0"/>
+              </a:rPr>
+              <a:t> ./</a:t>
+            </a:r>
+            <a:r>
+              <a:rPr lang="en-US" sz="1400" dirty="0" err="1">
+                <a:latin typeface="Consolas" panose="020B0609020204030204" pitchFamily="49" charset="0"/>
+              </a:rPr>
+              <a:t>VBoxLinuxAdditions.run</a:t>
+            </a:r>
+            <a:endParaRPr lang="en-US" sz="1400" dirty="0">
+              <a:latin typeface="Consolas" panose="020B0609020204030204" pitchFamily="49" charset="0"/>
+            </a:endParaRPr>
+          </a:p>
+          <a:p>
+            <a:pPr marL="971550" lvl="1" indent="-285750"/>
             <a:endParaRPr lang="en-US" sz="1600" dirty="0"/>
           </a:p>
           <a:p>
@@ -6539,6 +6789,206 @@
     <p:extLst>
       <p:ext uri="{BB962C8B-B14F-4D97-AF65-F5344CB8AC3E}">
         <p14:creationId xmlns:p14="http://schemas.microsoft.com/office/powerpoint/2010/main" val="1104338654"/>
+      </p:ext>
+    </p:extLst>
+  </p:cSld>
+  <p:clrMapOvr>
+    <a:masterClrMapping/>
+  </p:clrMapOvr>
+</p:sld>
+</file>
+
+<file path=ppt/slides/slide3.xml><?xml version="1.0" encoding="utf-8"?>
+<p:sld xmlns:a="http://schemas.openxmlformats.org/drawingml/2006/main" xmlns:r="http://schemas.openxmlformats.org/officeDocument/2006/relationships" xmlns:p="http://schemas.openxmlformats.org/presentationml/2006/main">
+  <p:cSld>
+    <p:spTree>
+      <p:nvGrpSpPr>
+        <p:cNvPr id="1" name="">
+          <a:extLst>
+            <a:ext uri="{FF2B5EF4-FFF2-40B4-BE49-F238E27FC236}">
+              <a16:creationId xmlns:a16="http://schemas.microsoft.com/office/drawing/2014/main" id="{82B78F6F-F291-7F57-329C-4313E6D439F5}"/>
+            </a:ext>
+          </a:extLst>
+        </p:cNvPr>
+        <p:cNvGrpSpPr/>
+        <p:nvPr/>
+      </p:nvGrpSpPr>
+      <p:grpSpPr>
+        <a:xfrm>
+          <a:off x="0" y="0"/>
+          <a:ext cx="0" cy="0"/>
+          <a:chOff x="0" y="0"/>
+          <a:chExt cx="0" cy="0"/>
+        </a:xfrm>
+      </p:grpSpPr>
+      <p:sp>
+        <p:nvSpPr>
+          <p:cNvPr id="2" name="Text Placeholder 1">
+            <a:extLst>
+              <a:ext uri="{FF2B5EF4-FFF2-40B4-BE49-F238E27FC236}">
+                <a16:creationId xmlns:a16="http://schemas.microsoft.com/office/drawing/2014/main" id="{D6CF6202-2596-ACE7-3DF0-7B2F529829F6}"/>
+              </a:ext>
+            </a:extLst>
+          </p:cNvPr>
+          <p:cNvSpPr>
+            <a:spLocks noGrp="1"/>
+          </p:cNvSpPr>
+          <p:nvPr>
+            <p:ph type="body" sz="quarter" idx="10"/>
+          </p:nvPr>
+        </p:nvSpPr>
+        <p:spPr/>
+        <p:txBody>
+          <a:bodyPr/>
+          <a:lstStyle/>
+          <a:p>
+            <a:r>
+              <a:rPr lang="en-US" dirty="0"/>
+              <a:t>Extra Kali Linux Setups</a:t>
+            </a:r>
+          </a:p>
+        </p:txBody>
+      </p:sp>
+      <p:sp>
+        <p:nvSpPr>
+          <p:cNvPr id="4" name="Text Placeholder 3">
+            <a:extLst>
+              <a:ext uri="{FF2B5EF4-FFF2-40B4-BE49-F238E27FC236}">
+                <a16:creationId xmlns:a16="http://schemas.microsoft.com/office/drawing/2014/main" id="{E8D768AE-10AC-5DA9-217E-2CCC11B2E084}"/>
+              </a:ext>
+            </a:extLst>
+          </p:cNvPr>
+          <p:cNvSpPr>
+            <a:spLocks noGrp="1"/>
+          </p:cNvSpPr>
+          <p:nvPr>
+            <p:ph type="body" sz="quarter" idx="12"/>
+          </p:nvPr>
+        </p:nvSpPr>
+        <p:spPr>
+          <a:xfrm>
+            <a:off x="270415" y="640080"/>
+            <a:ext cx="11658059" cy="6009888"/>
+          </a:xfrm>
+        </p:spPr>
+        <p:txBody>
+          <a:bodyPr>
+            <a:normAutofit/>
+          </a:bodyPr>
+          <a:lstStyle/>
+          <a:p>
+            <a:r>
+              <a:rPr lang="en-US" dirty="0"/>
+              <a:t>We’ll need to install some additional software and enable it for our labs:</a:t>
+            </a:r>
+          </a:p>
+          <a:p>
+            <a:r>
+              <a:rPr lang="en-US" dirty="0"/>
+              <a:t>First we’ll need to clone the </a:t>
+            </a:r>
+            <a:r>
+              <a:rPr lang="en-US" dirty="0" err="1"/>
+              <a:t>Github</a:t>
+            </a:r>
+            <a:r>
+              <a:rPr lang="en-US" dirty="0"/>
+              <a:t> repository and run a command:</a:t>
+            </a:r>
+          </a:p>
+          <a:p>
+            <a:endParaRPr lang="en-US" dirty="0"/>
+          </a:p>
+          <a:p>
+            <a:pPr marL="285750" indent="-285750">
+              <a:buFont typeface="Arial" panose="020B0604020202020204" pitchFamily="34" charset="0"/>
+              <a:buChar char="•"/>
+            </a:pPr>
+            <a:r>
+              <a:rPr lang="en-US" sz="1200" dirty="0">
+                <a:latin typeface="Consolas" panose="020B0609020204030204" pitchFamily="49" charset="0"/>
+              </a:rPr>
+              <a:t>git clone </a:t>
+            </a:r>
+            <a:r>
+              <a:rPr lang="en-US" sz="1200" u="sng" dirty="0">
+                <a:latin typeface="Consolas" panose="020B0609020204030204" pitchFamily="49" charset="0"/>
+                <a:hlinkClick r:id="rId2"/>
+              </a:rPr>
+              <a:t>https://github.com/nprobert/AutoISAC-ACT-AdvWireless.git</a:t>
+            </a:r>
+            <a:endParaRPr lang="en-US" sz="1200" u="sng" dirty="0">
+              <a:latin typeface="Consolas" panose="020B0609020204030204" pitchFamily="49" charset="0"/>
+            </a:endParaRPr>
+          </a:p>
+          <a:p>
+            <a:pPr marL="285750" indent="-285750">
+              <a:buFont typeface="Arial" panose="020B0604020202020204" pitchFamily="34" charset="0"/>
+              <a:buChar char="•"/>
+            </a:pPr>
+            <a:r>
+              <a:rPr lang="en-US" sz="1200" u="sng" dirty="0">
+                <a:latin typeface="Consolas" panose="020B0609020204030204" pitchFamily="49" charset="0"/>
+              </a:rPr>
+              <a:t>cd Auto-ISAC-ACT-</a:t>
+            </a:r>
+            <a:r>
+              <a:rPr lang="en-US" sz="1200" u="sng" dirty="0" err="1">
+                <a:latin typeface="Consolas" panose="020B0609020204030204" pitchFamily="49" charset="0"/>
+              </a:rPr>
+              <a:t>AdvWireless</a:t>
+            </a:r>
+            <a:r>
+              <a:rPr lang="en-US" sz="1200" u="sng" dirty="0">
+                <a:latin typeface="Consolas" panose="020B0609020204030204" pitchFamily="49" charset="0"/>
+              </a:rPr>
+              <a:t>/Linux</a:t>
+            </a:r>
+          </a:p>
+          <a:p>
+            <a:pPr marL="285750" indent="-285750">
+              <a:buFont typeface="Arial" panose="020B0604020202020204" pitchFamily="34" charset="0"/>
+              <a:buChar char="•"/>
+            </a:pPr>
+            <a:r>
+              <a:rPr lang="en-US" sz="1200" u="sng" dirty="0">
+                <a:latin typeface="Consolas" panose="020B0609020204030204" pitchFamily="49" charset="0"/>
+              </a:rPr>
+              <a:t>./kali-setup.sh</a:t>
+            </a:r>
+          </a:p>
+          <a:p>
+            <a:pPr marL="285750" indent="-285750">
+              <a:buFont typeface="Arial" panose="020B0604020202020204" pitchFamily="34" charset="0"/>
+              <a:buChar char="•"/>
+            </a:pPr>
+            <a:endParaRPr lang="en-US" sz="1600" dirty="0"/>
+          </a:p>
+          <a:p>
+            <a:pPr marL="971550" lvl="1" indent="-285750"/>
+            <a:endParaRPr lang="en-US" sz="1600" dirty="0"/>
+          </a:p>
+          <a:p>
+            <a:pPr marL="971550" lvl="1" indent="-285750"/>
+            <a:endParaRPr lang="en-US" sz="1600" dirty="0"/>
+          </a:p>
+          <a:p>
+            <a:pPr marL="285750" indent="-285750"/>
+            <a:endParaRPr lang="en-US" sz="1000" dirty="0"/>
+          </a:p>
+          <a:p>
+            <a:pPr marL="285750" indent="-285750"/>
+            <a:endParaRPr lang="en-US" sz="1000" dirty="0"/>
+          </a:p>
+          <a:p>
+            <a:endParaRPr lang="en-US" dirty="0"/>
+          </a:p>
+        </p:txBody>
+      </p:sp>
+    </p:spTree>
+    <p:extLst>
+      <p:ext uri="{BB962C8B-B14F-4D97-AF65-F5344CB8AC3E}">
+        <p14:creationId xmlns:p14="http://schemas.microsoft.com/office/powerpoint/2010/main" val="1108113820"/>
       </p:ext>
     </p:extLst>
   </p:cSld>
@@ -7186,6 +7636,15 @@
 </file>
 
 <file path=customXml/item1.xml><?xml version="1.0" encoding="utf-8"?>
+<?mso-contentType ?>
+<FormTemplates xmlns="http://schemas.microsoft.com/sharepoint/v3/contenttype/forms">
+  <Display>DocumentLibraryForm</Display>
+  <Edit>DocumentLibraryForm</Edit>
+  <New>DocumentLibraryForm</New>
+</FormTemplates>
+</file>
+
+<file path=customXml/item2.xml><?xml version="1.0" encoding="utf-8"?>
 <ct:contentTypeSchema xmlns:ct="http://schemas.microsoft.com/office/2006/metadata/contentType" xmlns:ma="http://schemas.microsoft.com/office/2006/metadata/properties/metaAttributes" ct:_="" ma:_="" ma:contentTypeName="Document" ma:contentTypeID="0x01010067B86F8708159745A0B6896184DE9576" ma:contentTypeVersion="19" ma:contentTypeDescription="Create a new document." ma:contentTypeScope="" ma:versionID="493bf26d373952ea1ae3b9e24cd19b33">
   <xsd:schema xmlns:xsd="http://www.w3.org/2001/XMLSchema" xmlns:xs="http://www.w3.org/2001/XMLSchema" xmlns:p="http://schemas.microsoft.com/office/2006/metadata/properties" xmlns:ns2="c7a77415-c4a3-4262-8430-671f3e8707b6" xmlns:ns3="69a7259e-7a2c-42d5-bc84-25eccf0dce8b" targetNamespace="http://schemas.microsoft.com/office/2006/metadata/properties" ma:root="true" ma:fieldsID="69c00e31f84d56e19bb090b7ea67ab52" ns2:_="" ns3:_="">
     <xsd:import namespace="c7a77415-c4a3-4262-8430-671f3e8707b6"/>
@@ -7471,16 +7930,23 @@
 </ct:contentTypeSchema>
 </file>
 
-<file path=customXml/item2.xml><?xml version="1.0" encoding="utf-8"?>
-<?mso-contentType ?>
-<FormTemplates xmlns="http://schemas.microsoft.com/sharepoint/v3/contenttype/forms">
-  <Display>DocumentLibraryForm</Display>
-  <Edit>DocumentLibraryForm</Edit>
-  <New>DocumentLibraryForm</New>
-</FormTemplates>
+<file path=customXml/item3.xml><?xml version="1.0" encoding="utf-8"?>
+<p:properties xmlns:p="http://schemas.microsoft.com/office/2006/metadata/properties" xmlns:xsi="http://www.w3.org/2001/XMLSchema-instance" xmlns:pc="http://schemas.microsoft.com/office/infopath/2007/PartnerControls">
+  <documentManagement>
+    <_dlc_DocId xmlns="c7a77415-c4a3-4262-8430-671f3e8707b6">7J4PPY27XH2W-901365475-257158</_dlc_DocId>
+    <_dlc_DocIdUrl xmlns="c7a77415-c4a3-4262-8430-671f3e8707b6">
+      <Url>https://automotivei.sharepoint.com/sites/PMO/_layouts/15/DocIdRedir.aspx?ID=7J4PPY27XH2W-901365475-257158</Url>
+      <Description>7J4PPY27XH2W-901365475-257158</Description>
+    </_dlc_DocIdUrl>
+    <TaxCatchAll xmlns="c7a77415-c4a3-4262-8430-671f3e8707b6" xsi:nil="true"/>
+    <lcf76f155ced4ddcb4097134ff3c332f xmlns="69a7259e-7a2c-42d5-bc84-25eccf0dce8b">
+      <Terms xmlns="http://schemas.microsoft.com/office/infopath/2007/PartnerControls"/>
+    </lcf76f155ced4ddcb4097134ff3c332f>
+  </documentManagement>
+</p:properties>
 </file>
 
-<file path=customXml/item3.xml><?xml version="1.0" encoding="utf-8"?>
+<file path=customXml/item4.xml><?xml version="1.0" encoding="utf-8"?>
 <?mso-contentType ?>
 <spe:Receivers xmlns:spe="http://schemas.microsoft.com/sharepoint/events">
   <Receiver>
@@ -7530,23 +7996,15 @@
 </spe:Receivers>
 </file>
 
-<file path=customXml/item4.xml><?xml version="1.0" encoding="utf-8"?>
-<p:properties xmlns:p="http://schemas.microsoft.com/office/2006/metadata/properties" xmlns:xsi="http://www.w3.org/2001/XMLSchema-instance" xmlns:pc="http://schemas.microsoft.com/office/infopath/2007/PartnerControls">
-  <documentManagement>
-    <_dlc_DocId xmlns="c7a77415-c4a3-4262-8430-671f3e8707b6">7J4PPY27XH2W-901365475-257158</_dlc_DocId>
-    <_dlc_DocIdUrl xmlns="c7a77415-c4a3-4262-8430-671f3e8707b6">
-      <Url>https://automotivei.sharepoint.com/sites/PMO/_layouts/15/DocIdRedir.aspx?ID=7J4PPY27XH2W-901365475-257158</Url>
-      <Description>7J4PPY27XH2W-901365475-257158</Description>
-    </_dlc_DocIdUrl>
-    <TaxCatchAll xmlns="c7a77415-c4a3-4262-8430-671f3e8707b6" xsi:nil="true"/>
-    <lcf76f155ced4ddcb4097134ff3c332f xmlns="69a7259e-7a2c-42d5-bc84-25eccf0dce8b">
-      <Terms xmlns="http://schemas.microsoft.com/office/infopath/2007/PartnerControls"/>
-    </lcf76f155ced4ddcb4097134ff3c332f>
-  </documentManagement>
-</p:properties>
+<file path=customXml/itemProps1.xml><?xml version="1.0" encoding="utf-8"?>
+<ds:datastoreItem xmlns:ds="http://schemas.openxmlformats.org/officeDocument/2006/customXml" ds:itemID="{84EE72F3-C956-4A5B-833F-E761B5D8ACD8}">
+  <ds:schemaRefs>
+    <ds:schemaRef ds:uri="http://schemas.microsoft.com/sharepoint/v3/contenttype/forms"/>
+  </ds:schemaRefs>
+</ds:datastoreItem>
 </file>
 
-<file path=customXml/itemProps1.xml><?xml version="1.0" encoding="utf-8"?>
+<file path=customXml/itemProps2.xml><?xml version="1.0" encoding="utf-8"?>
 <ds:datastoreItem xmlns:ds="http://schemas.openxmlformats.org/officeDocument/2006/customXml" ds:itemID="{8FEF19B7-7529-453B-A7D5-A8465340F17A}">
   <ds:schemaRefs>
     <ds:schemaRef ds:uri="http://schemas.microsoft.com/office/2006/metadata/contentType"/>
@@ -7565,23 +8023,7 @@
 </ds:datastoreItem>
 </file>
 
-<file path=customXml/itemProps2.xml><?xml version="1.0" encoding="utf-8"?>
-<ds:datastoreItem xmlns:ds="http://schemas.openxmlformats.org/officeDocument/2006/customXml" ds:itemID="{84EE72F3-C956-4A5B-833F-E761B5D8ACD8}">
-  <ds:schemaRefs>
-    <ds:schemaRef ds:uri="http://schemas.microsoft.com/sharepoint/v3/contenttype/forms"/>
-  </ds:schemaRefs>
-</ds:datastoreItem>
-</file>
-
 <file path=customXml/itemProps3.xml><?xml version="1.0" encoding="utf-8"?>
-<ds:datastoreItem xmlns:ds="http://schemas.openxmlformats.org/officeDocument/2006/customXml" ds:itemID="{54C592EF-85C1-482B-896B-DED434B6FCCC}">
-  <ds:schemaRefs>
-    <ds:schemaRef ds:uri="http://schemas.microsoft.com/sharepoint/events"/>
-  </ds:schemaRefs>
-</ds:datastoreItem>
-</file>
-
-<file path=customXml/itemProps4.xml><?xml version="1.0" encoding="utf-8"?>
 <ds:datastoreItem xmlns:ds="http://schemas.openxmlformats.org/officeDocument/2006/customXml" ds:itemID="{E71A463F-9F4B-47AC-91AA-3962FD8F3CE5}">
   <ds:schemaRefs>
     <ds:schemaRef ds:uri="http://schemas.microsoft.com/office/2006/metadata/properties"/>
@@ -7590,4 +8032,12 @@
     <ds:schemaRef ds:uri="69a7259e-7a2c-42d5-bc84-25eccf0dce8b"/>
   </ds:schemaRefs>
 </ds:datastoreItem>
+</file>
+
+<file path=customXml/itemProps4.xml><?xml version="1.0" encoding="utf-8"?>
+<ds:datastoreItem xmlns:ds="http://schemas.openxmlformats.org/officeDocument/2006/customXml" ds:itemID="{54C592EF-85C1-482B-896B-DED434B6FCCC}">
+  <ds:schemaRefs>
+    <ds:schemaRef ds:uri="http://schemas.microsoft.com/sharepoint/events"/>
+  </ds:schemaRefs>
+</ds:datastoreItem>
 </file>
</xml_diff>